<commit_message>
Update 상식 퀴즈 assets and add ZIP slides
Co-Authored-By: Claude Opus 4.6 (1M context) <noreply@anthropic.com>
</commit_message>
<xml_diff>
--- a/public/downloads/games/common-sense-quiz/rules.pptx
+++ b/public/downloads/games/common-sense-quiz/rules.pptx
@@ -55,16 +55,12 @@
   <p:notesSz cx="6858000" cy="9144000"/>
   <p:embeddedFontLst>
     <p:embeddedFont>
-      <p:font typeface="Jua" charset="1" panose="00000000000000000000"/>
+      <p:font typeface="무궁화 고딕" charset="1" panose="02020603020101020101"/>
       <p:regular r:id="rId51"/>
     </p:embeddedFont>
     <p:embeddedFont>
-      <p:font typeface="TDTD갬성명조" charset="1" panose="02000503000000000000"/>
+      <p:font typeface="무궁화 고딕 Bold" charset="1" panose="02020603020101020101"/>
       <p:regular r:id="rId52"/>
-    </p:embeddedFont>
-    <p:embeddedFont>
-      <p:font typeface="TDTD가온" charset="1" panose="02000503000000000000"/>
-      <p:regular r:id="rId53"/>
     </p:embeddedFont>
   </p:embeddedFontLst>
   <p:defaultTextStyle>
@@ -3182,8 +3178,8 @@
         </p:nvSpPr>
         <p:spPr>
           <a:xfrm rot="0">
-            <a:off x="1028700" y="3892867"/>
-            <a:ext cx="15555091" cy="2200275"/>
+            <a:off x="1028700" y="4178617"/>
+            <a:ext cx="15555091" cy="1914525"/>
           </a:xfrm>
           <a:prstGeom prst="rect">
             <a:avLst/>
@@ -3205,10 +3201,10 @@
                 <a:solidFill>
                   <a:srgbClr val="FFFAEF"/>
                 </a:solidFill>
-                <a:latin typeface="Jua"/>
-                <a:ea typeface="Jua"/>
-                <a:cs typeface="Jua"/>
-                <a:sym typeface="Jua"/>
+                <a:latin typeface="무궁화 고딕"/>
+                <a:ea typeface="무궁화 고딕"/>
+                <a:cs typeface="무궁화 고딕"/>
+                <a:sym typeface="무궁화 고딕"/>
               </a:rPr>
               <a:t>상식 퀴즈</a:t>
             </a:r>
@@ -3223,8 +3219,8 @@
         </p:nvSpPr>
         <p:spPr>
           <a:xfrm rot="0">
-            <a:off x="15264803" y="9812655"/>
-            <a:ext cx="2637975" cy="474345"/>
+            <a:off x="14683277" y="9822180"/>
+            <a:ext cx="3219502" cy="464820"/>
           </a:xfrm>
           <a:prstGeom prst="rect">
             <a:avLst/>
@@ -3249,10 +3245,10 @@
                 <a:solidFill>
                   <a:srgbClr val="FFFFFF"/>
                 </a:solidFill>
-                <a:latin typeface="TDTD갬성명조"/>
-                <a:ea typeface="TDTD갬성명조"/>
-                <a:cs typeface="TDTD갬성명조"/>
-                <a:sym typeface="TDTD갬성명조"/>
+                <a:latin typeface="무궁화 고딕"/>
+                <a:ea typeface="무궁화 고딕"/>
+                <a:cs typeface="무궁화 고딕"/>
+                <a:sym typeface="무궁화 고딕"/>
               </a:rPr>
               <a:t>ⓒ 2026. Sunday Play</a:t>
             </a:r>
@@ -3349,8 +3345,8 @@
         </p:nvSpPr>
         <p:spPr>
           <a:xfrm rot="0">
-            <a:off x="2717556" y="3933825"/>
-            <a:ext cx="12852888" cy="2124075"/>
+            <a:off x="2717556" y="4219575"/>
+            <a:ext cx="12852888" cy="1838325"/>
           </a:xfrm>
           <a:prstGeom prst="rect">
             <a:avLst/>
@@ -3372,10 +3368,10 @@
                 <a:solidFill>
                   <a:srgbClr val="000000"/>
                 </a:solidFill>
-                <a:latin typeface="Jua"/>
-                <a:ea typeface="Jua"/>
-                <a:cs typeface="Jua"/>
-                <a:sym typeface="Jua"/>
+                <a:latin typeface="무궁화 고딕"/>
+                <a:ea typeface="무궁화 고딕"/>
+                <a:cs typeface="무궁화 고딕"/>
+                <a:sym typeface="무궁화 고딕"/>
               </a:rPr>
               <a:t>세종대왕</a:t>
             </a:r>
@@ -3472,8 +3468,8 @@
         </p:nvSpPr>
         <p:spPr>
           <a:xfrm rot="0">
-            <a:off x="1135011" y="4029075"/>
-            <a:ext cx="16017978" cy="1952625"/>
+            <a:off x="1135011" y="4357687"/>
+            <a:ext cx="16017978" cy="1562100"/>
           </a:xfrm>
           <a:prstGeom prst="rect">
             <a:avLst/>
@@ -3487,18 +3483,18 @@
           <a:p>
             <a:pPr algn="ctr">
               <a:lnSpc>
-                <a:spcPts val="13200"/>
+                <a:spcPts val="12240"/>
               </a:lnSpc>
             </a:pPr>
             <a:r>
-              <a:rPr lang="en-US" sz="11000">
+              <a:rPr lang="en-US" sz="10200">
                 <a:solidFill>
                   <a:srgbClr val="000000"/>
                 </a:solidFill>
-                <a:latin typeface="Jua"/>
-                <a:ea typeface="Jua"/>
-                <a:cs typeface="Jua"/>
-                <a:sym typeface="Jua"/>
+                <a:latin typeface="무궁화 고딕"/>
+                <a:ea typeface="무궁화 고딕"/>
+                <a:cs typeface="무궁화 고딕"/>
+                <a:sym typeface="무궁화 고딕"/>
               </a:rPr>
               <a:t>물이 끓는 온도는 몇 도일까요?</a:t>
             </a:r>
@@ -3595,8 +3591,8 @@
         </p:nvSpPr>
         <p:spPr>
           <a:xfrm rot="0">
-            <a:off x="2717556" y="3933825"/>
-            <a:ext cx="12852888" cy="2124075"/>
+            <a:off x="2717556" y="4219575"/>
+            <a:ext cx="12852888" cy="1838325"/>
           </a:xfrm>
           <a:prstGeom prst="rect">
             <a:avLst/>
@@ -3618,10 +3614,10 @@
                 <a:solidFill>
                   <a:srgbClr val="000000"/>
                 </a:solidFill>
-                <a:latin typeface="Jua"/>
-                <a:ea typeface="Jua"/>
-                <a:cs typeface="Jua"/>
-                <a:sym typeface="Jua"/>
+                <a:latin typeface="무궁화 고딕"/>
+                <a:ea typeface="무궁화 고딕"/>
+                <a:cs typeface="무궁화 고딕"/>
+                <a:sym typeface="무궁화 고딕"/>
               </a:rPr>
               <a:t>100도</a:t>
             </a:r>
@@ -3718,8 +3714,8 @@
         </p:nvSpPr>
         <p:spPr>
           <a:xfrm rot="0">
-            <a:off x="1135011" y="4029075"/>
-            <a:ext cx="16017978" cy="1952625"/>
+            <a:off x="1135011" y="4295775"/>
+            <a:ext cx="16017978" cy="1685925"/>
           </a:xfrm>
           <a:prstGeom prst="rect">
             <a:avLst/>
@@ -3741,10 +3737,10 @@
                 <a:solidFill>
                   <a:srgbClr val="000000"/>
                 </a:solidFill>
-                <a:latin typeface="Jua"/>
-                <a:ea typeface="Jua"/>
-                <a:cs typeface="Jua"/>
-                <a:sym typeface="Jua"/>
+                <a:latin typeface="무궁화 고딕"/>
+                <a:ea typeface="무궁화 고딕"/>
+                <a:cs typeface="무궁화 고딕"/>
+                <a:sym typeface="무궁화 고딕"/>
               </a:rPr>
               <a:t>축구 한 팀은 몇 명일까요?</a:t>
             </a:r>
@@ -3841,8 +3837,8 @@
         </p:nvSpPr>
         <p:spPr>
           <a:xfrm rot="0">
-            <a:off x="2717556" y="3933825"/>
-            <a:ext cx="12852888" cy="2124075"/>
+            <a:off x="2717556" y="4219575"/>
+            <a:ext cx="12852888" cy="1838325"/>
           </a:xfrm>
           <a:prstGeom prst="rect">
             <a:avLst/>
@@ -3864,10 +3860,10 @@
                 <a:solidFill>
                   <a:srgbClr val="000000"/>
                 </a:solidFill>
-                <a:latin typeface="Jua"/>
-                <a:ea typeface="Jua"/>
-                <a:cs typeface="Jua"/>
-                <a:sym typeface="Jua"/>
+                <a:latin typeface="무궁화 고딕"/>
+                <a:ea typeface="무궁화 고딕"/>
+                <a:cs typeface="무궁화 고딕"/>
+                <a:sym typeface="무궁화 고딕"/>
               </a:rPr>
               <a:t>11명</a:t>
             </a:r>
@@ -3964,8 +3960,8 @@
         </p:nvSpPr>
         <p:spPr>
           <a:xfrm rot="0">
-            <a:off x="2717556" y="3019425"/>
-            <a:ext cx="12852888" cy="3952875"/>
+            <a:off x="2717556" y="3305175"/>
+            <a:ext cx="12852888" cy="3667125"/>
           </a:xfrm>
           <a:prstGeom prst="rect">
             <a:avLst/>
@@ -3987,10 +3983,10 @@
                 <a:solidFill>
                   <a:srgbClr val="000000"/>
                 </a:solidFill>
-                <a:latin typeface="Jua"/>
-                <a:ea typeface="Jua"/>
-                <a:cs typeface="Jua"/>
-                <a:sym typeface="Jua"/>
+                <a:latin typeface="무궁화 고딕"/>
+                <a:ea typeface="무궁화 고딕"/>
+                <a:cs typeface="무궁화 고딕"/>
+                <a:sym typeface="무궁화 고딕"/>
               </a:rPr>
               <a:t>세계에서 가장 높은</a:t>
             </a:r>
@@ -4006,10 +4002,10 @@
                 <a:solidFill>
                   <a:srgbClr val="000000"/>
                 </a:solidFill>
-                <a:latin typeface="Jua"/>
-                <a:ea typeface="Jua"/>
-                <a:cs typeface="Jua"/>
-                <a:sym typeface="Jua"/>
+                <a:latin typeface="무궁화 고딕"/>
+                <a:ea typeface="무궁화 고딕"/>
+                <a:cs typeface="무궁화 고딕"/>
+                <a:sym typeface="무궁화 고딕"/>
               </a:rPr>
               <a:t>산은 무엇일까요?</a:t>
             </a:r>
@@ -4106,8 +4102,8 @@
         </p:nvSpPr>
         <p:spPr>
           <a:xfrm rot="0">
-            <a:off x="1135011" y="4029075"/>
-            <a:ext cx="16017978" cy="1952625"/>
+            <a:off x="1135011" y="4295775"/>
+            <a:ext cx="16017978" cy="1685925"/>
           </a:xfrm>
           <a:prstGeom prst="rect">
             <a:avLst/>
@@ -4129,10 +4125,10 @@
                 <a:solidFill>
                   <a:srgbClr val="000000"/>
                 </a:solidFill>
-                <a:latin typeface="Jua"/>
-                <a:ea typeface="Jua"/>
-                <a:cs typeface="Jua"/>
-                <a:sym typeface="Jua"/>
+                <a:latin typeface="무궁화 고딕"/>
+                <a:ea typeface="무궁화 고딕"/>
+                <a:cs typeface="무궁화 고딕"/>
+                <a:sym typeface="무궁화 고딕"/>
               </a:rPr>
               <a:t>에베레스트 산</a:t>
             </a:r>
@@ -4229,8 +4225,8 @@
         </p:nvSpPr>
         <p:spPr>
           <a:xfrm rot="0">
-            <a:off x="1135011" y="2352675"/>
-            <a:ext cx="16017978" cy="5305425"/>
+            <a:off x="1135011" y="2619375"/>
+            <a:ext cx="16017978" cy="5038725"/>
           </a:xfrm>
           <a:prstGeom prst="rect">
             <a:avLst/>
@@ -4252,10 +4248,10 @@
                 <a:solidFill>
                   <a:srgbClr val="000000"/>
                 </a:solidFill>
-                <a:latin typeface="Jua"/>
-                <a:ea typeface="Jua"/>
-                <a:cs typeface="Jua"/>
-                <a:sym typeface="Jua"/>
+                <a:latin typeface="무궁화 고딕"/>
+                <a:ea typeface="무궁화 고딕"/>
+                <a:cs typeface="무궁화 고딕"/>
+                <a:sym typeface="무궁화 고딕"/>
               </a:rPr>
               <a:t>트럼프 카드 한 묶음은</a:t>
             </a:r>
@@ -4271,10 +4267,10 @@
                 <a:solidFill>
                   <a:srgbClr val="000000"/>
                 </a:solidFill>
-                <a:latin typeface="Jua"/>
-                <a:ea typeface="Jua"/>
-                <a:cs typeface="Jua"/>
-                <a:sym typeface="Jua"/>
+                <a:latin typeface="무궁화 고딕"/>
+                <a:ea typeface="무궁화 고딕"/>
+                <a:cs typeface="무궁화 고딕"/>
+                <a:sym typeface="무궁화 고딕"/>
               </a:rPr>
               <a:t>총 몇 장일까요?</a:t>
             </a:r>
@@ -4290,10 +4286,10 @@
                 <a:solidFill>
                   <a:srgbClr val="000000"/>
                 </a:solidFill>
-                <a:latin typeface="Jua"/>
-                <a:ea typeface="Jua"/>
-                <a:cs typeface="Jua"/>
-                <a:sym typeface="Jua"/>
+                <a:latin typeface="무궁화 고딕"/>
+                <a:ea typeface="무궁화 고딕"/>
+                <a:cs typeface="무궁화 고딕"/>
+                <a:sym typeface="무궁화 고딕"/>
               </a:rPr>
               <a:t>(조커 제외)</a:t>
             </a:r>
@@ -4390,8 +4386,8 @@
         </p:nvSpPr>
         <p:spPr>
           <a:xfrm rot="0">
-            <a:off x="2717556" y="3933825"/>
-            <a:ext cx="12852888" cy="2124075"/>
+            <a:off x="2717556" y="4219575"/>
+            <a:ext cx="12852888" cy="1838325"/>
           </a:xfrm>
           <a:prstGeom prst="rect">
             <a:avLst/>
@@ -4413,10 +4409,10 @@
                 <a:solidFill>
                   <a:srgbClr val="000000"/>
                 </a:solidFill>
-                <a:latin typeface="Jua"/>
-                <a:ea typeface="Jua"/>
-                <a:cs typeface="Jua"/>
-                <a:sym typeface="Jua"/>
+                <a:latin typeface="무궁화 고딕"/>
+                <a:ea typeface="무궁화 고딕"/>
+                <a:cs typeface="무궁화 고딕"/>
+                <a:sym typeface="무궁화 고딕"/>
               </a:rPr>
               <a:t>52장</a:t>
             </a:r>
@@ -4513,8 +4509,8 @@
         </p:nvSpPr>
         <p:spPr>
           <a:xfrm rot="0">
-            <a:off x="1135011" y="4029075"/>
-            <a:ext cx="16017978" cy="1952625"/>
+            <a:off x="1135011" y="4343400"/>
+            <a:ext cx="16017978" cy="1590675"/>
           </a:xfrm>
           <a:prstGeom prst="rect">
             <a:avLst/>
@@ -4528,18 +4524,18 @@
           <a:p>
             <a:pPr algn="ctr">
               <a:lnSpc>
-                <a:spcPts val="13200"/>
+                <a:spcPts val="12480"/>
               </a:lnSpc>
             </a:pPr>
             <a:r>
-              <a:rPr lang="en-US" sz="11000">
+              <a:rPr lang="en-US" sz="10400">
                 <a:solidFill>
                   <a:srgbClr val="000000"/>
                 </a:solidFill>
-                <a:latin typeface="Jua"/>
-                <a:ea typeface="Jua"/>
-                <a:cs typeface="Jua"/>
-                <a:sym typeface="Jua"/>
+                <a:latin typeface="무궁화 고딕"/>
+                <a:ea typeface="무궁화 고딕"/>
+                <a:cs typeface="무궁화 고딕"/>
+                <a:sym typeface="무궁화 고딕"/>
               </a:rPr>
               <a:t>올림픽은 몇 년마다 열릴까요?</a:t>
             </a:r>
@@ -4688,8 +4684,8 @@
         </p:nvSpPr>
         <p:spPr>
           <a:xfrm rot="0">
-            <a:off x="11392761" y="600705"/>
-            <a:ext cx="5362043" cy="1600200"/>
+            <a:off x="11392761" y="819780"/>
+            <a:ext cx="5362043" cy="1381125"/>
           </a:xfrm>
           <a:prstGeom prst="rect">
             <a:avLst/>
@@ -4711,10 +4707,10 @@
                 <a:solidFill>
                   <a:srgbClr val="FFFAEF"/>
                 </a:solidFill>
-                <a:latin typeface="Jua"/>
-                <a:ea typeface="Jua"/>
-                <a:cs typeface="Jua"/>
-                <a:sym typeface="Jua"/>
+                <a:latin typeface="무궁화 고딕"/>
+                <a:ea typeface="무궁화 고딕"/>
+                <a:cs typeface="무궁화 고딕"/>
+                <a:sym typeface="무궁화 고딕"/>
               </a:rPr>
               <a:t>규칙</a:t>
             </a:r>
@@ -4730,9 +4726,9 @@
         <p:grpSpPr>
           <a:xfrm rot="0">
             <a:off x="217650" y="223900"/>
-            <a:ext cx="10360529" cy="2056505"/>
+            <a:ext cx="10939580" cy="2002541"/>
             <a:chOff x="0" y="0"/>
-            <a:chExt cx="13814039" cy="2742007"/>
+            <a:chExt cx="14586106" cy="2670055"/>
           </a:xfrm>
         </p:grpSpPr>
         <p:sp>
@@ -4743,8 +4739,8 @@
           </p:nvSpPr>
           <p:spPr>
             <a:xfrm rot="0">
-              <a:off x="0" y="1625465"/>
-              <a:ext cx="13814039" cy="1116542"/>
+              <a:off x="0" y="1725517"/>
+              <a:ext cx="14586106" cy="944538"/>
             </a:xfrm>
             <a:prstGeom prst="rect">
               <a:avLst/>
@@ -4758,18 +4754,18 @@
             <a:p>
               <a:pPr algn="l">
                 <a:lnSpc>
-                  <a:spcPts val="7000"/>
+                  <a:spcPts val="5912"/>
                 </a:lnSpc>
               </a:pPr>
               <a:r>
-                <a:rPr lang="en-US" sz="5000">
+                <a:rPr lang="en-US" sz="4223">
                   <a:solidFill>
                     <a:srgbClr val="FFFAEF"/>
                   </a:solidFill>
-                  <a:latin typeface="TDTD가온"/>
-                  <a:ea typeface="TDTD가온"/>
-                  <a:cs typeface="TDTD가온"/>
-                  <a:sym typeface="TDTD가온"/>
+                  <a:latin typeface="무궁화 고딕"/>
+                  <a:ea typeface="무궁화 고딕"/>
+                  <a:cs typeface="무궁화 고딕"/>
+                  <a:sym typeface="무궁화 고딕"/>
                 </a:rPr>
                 <a:t>화면에 상식 문제가 나타납니다.</a:t>
               </a:r>
@@ -4784,8 +4780,8 @@
           </p:nvSpPr>
           <p:spPr>
             <a:xfrm rot="0">
-              <a:off x="0" y="-190500"/>
-              <a:ext cx="11298371" cy="1367863"/>
+              <a:off x="0" y="-66675"/>
+              <a:ext cx="11929837" cy="1303665"/>
             </a:xfrm>
             <a:prstGeom prst="rect">
               <a:avLst/>
@@ -4799,18 +4795,18 @@
             <a:p>
               <a:pPr algn="l">
                 <a:lnSpc>
-                  <a:spcPts val="7560"/>
+                  <a:spcPts val="7983"/>
                 </a:lnSpc>
               </a:pPr>
               <a:r>
-                <a:rPr lang="en-US" sz="5816">
+                <a:rPr lang="en-US" sz="6141">
                   <a:solidFill>
                     <a:srgbClr val="FFFAEF"/>
                   </a:solidFill>
-                  <a:latin typeface="Jua"/>
-                  <a:ea typeface="Jua"/>
-                  <a:cs typeface="Jua"/>
-                  <a:sym typeface="Jua"/>
+                  <a:latin typeface="무궁화 고딕 Bold"/>
+                  <a:ea typeface="무궁화 고딕 Bold"/>
+                  <a:cs typeface="무궁화 고딕 Bold"/>
+                  <a:sym typeface="무궁화 고딕 Bold"/>
                 </a:rPr>
                 <a:t>STEP 1.</a:t>
               </a:r>
@@ -4826,10 +4822,10 @@
         </p:nvGrpSpPr>
         <p:grpSpPr>
           <a:xfrm rot="0">
-            <a:off x="9144000" y="7809938"/>
-            <a:ext cx="9144000" cy="1994512"/>
+            <a:off x="10161695" y="7860464"/>
+            <a:ext cx="8126305" cy="1938277"/>
             <a:chOff x="0" y="0"/>
-            <a:chExt cx="12192000" cy="2659349"/>
+            <a:chExt cx="10835074" cy="2584369"/>
           </a:xfrm>
         </p:grpSpPr>
         <p:sp>
@@ -4840,8 +4836,8 @@
           </p:nvSpPr>
           <p:spPr>
             <a:xfrm rot="0">
-              <a:off x="0" y="1542808"/>
-              <a:ext cx="12076089" cy="1116541"/>
+              <a:off x="0" y="1641335"/>
+              <a:ext cx="10732064" cy="943034"/>
             </a:xfrm>
             <a:prstGeom prst="rect">
               <a:avLst/>
@@ -4855,18 +4851,18 @@
             <a:p>
               <a:pPr algn="l">
                 <a:lnSpc>
-                  <a:spcPts val="7000"/>
+                  <a:spcPts val="5902"/>
                 </a:lnSpc>
               </a:pPr>
               <a:r>
-                <a:rPr lang="en-US" sz="5000">
+                <a:rPr lang="en-US" sz="4216">
                   <a:solidFill>
                     <a:srgbClr val="FFFAEF"/>
                   </a:solidFill>
-                  <a:latin typeface="TDTD가온"/>
-                  <a:ea typeface="TDTD가온"/>
-                  <a:cs typeface="TDTD가온"/>
-                  <a:sym typeface="TDTD가온"/>
+                  <a:latin typeface="무궁화 고딕"/>
+                  <a:ea typeface="무궁화 고딕"/>
+                  <a:cs typeface="무궁화 고딕"/>
+                  <a:sym typeface="무궁화 고딕"/>
                 </a:rPr>
                 <a:t>가장 많은 문제를 맞춘  팀이 우승!</a:t>
               </a:r>
@@ -4881,8 +4877,8 @@
           </p:nvSpPr>
           <p:spPr>
             <a:xfrm rot="0">
-              <a:off x="0" y="-190500"/>
-              <a:ext cx="12192000" cy="1374479"/>
+              <a:off x="0" y="-66675"/>
+              <a:ext cx="10835074" cy="1314612"/>
             </a:xfrm>
             <a:prstGeom prst="rect">
               <a:avLst/>
@@ -4896,18 +4892,18 @@
             <a:p>
               <a:pPr algn="l">
                 <a:lnSpc>
-                  <a:spcPts val="7578"/>
+                  <a:spcPts val="7988"/>
                 </a:lnSpc>
               </a:pPr>
               <a:r>
-                <a:rPr lang="en-US" sz="5829">
+                <a:rPr lang="en-US" sz="6144">
                   <a:solidFill>
                     <a:srgbClr val="FFFAEF"/>
                   </a:solidFill>
-                  <a:latin typeface="Jua"/>
-                  <a:ea typeface="Jua"/>
-                  <a:cs typeface="Jua"/>
-                  <a:sym typeface="Jua"/>
+                  <a:latin typeface="무궁화 고딕 Bold"/>
+                  <a:ea typeface="무궁화 고딕 Bold"/>
+                  <a:cs typeface="무궁화 고딕 Bold"/>
+                  <a:sym typeface="무궁화 고딕 Bold"/>
                 </a:rPr>
                 <a:t>STEP 3.</a:t>
               </a:r>
@@ -4923,10 +4919,10 @@
         </p:nvGrpSpPr>
         <p:grpSpPr>
           <a:xfrm rot="0">
-            <a:off x="5397915" y="3511566"/>
-            <a:ext cx="7371077" cy="2939517"/>
+            <a:off x="5239734" y="3667979"/>
+            <a:ext cx="7808533" cy="2750947"/>
             <a:chOff x="0" y="0"/>
-            <a:chExt cx="9828103" cy="3919356"/>
+            <a:chExt cx="10411377" cy="3667930"/>
           </a:xfrm>
         </p:grpSpPr>
         <p:sp>
@@ -4937,8 +4933,8 @@
           </p:nvSpPr>
           <p:spPr>
             <a:xfrm rot="0">
-              <a:off x="0" y="1631121"/>
-              <a:ext cx="9828103" cy="2288235"/>
+              <a:off x="0" y="1734561"/>
+              <a:ext cx="10411377" cy="1933369"/>
             </a:xfrm>
             <a:prstGeom prst="rect">
               <a:avLst/>
@@ -4952,18 +4948,18 @@
             <a:p>
               <a:pPr algn="l">
                 <a:lnSpc>
-                  <a:spcPts val="6995"/>
+                  <a:spcPts val="5932"/>
                 </a:lnSpc>
               </a:pPr>
               <a:r>
-                <a:rPr lang="en-US" sz="4996">
+                <a:rPr lang="en-US" sz="4237">
                   <a:solidFill>
                     <a:srgbClr val="FFFAEF"/>
                   </a:solidFill>
-                  <a:latin typeface="TDTD가온"/>
-                  <a:ea typeface="TDTD가온"/>
-                  <a:cs typeface="TDTD가온"/>
-                  <a:sym typeface="TDTD가온"/>
+                  <a:latin typeface="무궁화 고딕"/>
+                  <a:ea typeface="무궁화 고딕"/>
+                  <a:cs typeface="무궁화 고딕"/>
+                  <a:sym typeface="무궁화 고딕"/>
                 </a:rPr>
                 <a:t>팀 구호(혹은 정답)를 가장 먼저</a:t>
               </a:r>
@@ -4971,18 +4967,18 @@
             <a:p>
               <a:pPr algn="l">
                 <a:lnSpc>
-                  <a:spcPts val="6995"/>
+                  <a:spcPts val="5932"/>
                 </a:lnSpc>
               </a:pPr>
               <a:r>
-                <a:rPr lang="en-US" sz="4996">
+                <a:rPr lang="en-US" sz="4237">
                   <a:solidFill>
                     <a:srgbClr val="FFFAEF"/>
                   </a:solidFill>
-                  <a:latin typeface="TDTD가온"/>
-                  <a:ea typeface="TDTD가온"/>
-                  <a:cs typeface="TDTD가온"/>
-                  <a:sym typeface="TDTD가온"/>
+                  <a:latin typeface="무궁화 고딕"/>
+                  <a:ea typeface="무궁화 고딕"/>
+                  <a:cs typeface="무궁화 고딕"/>
+                  <a:sym typeface="무궁화 고딕"/>
                 </a:rPr>
                 <a:t>외친 팀에게 기회가 주어집니다.</a:t>
               </a:r>
@@ -4997,8 +4993,8 @@
           </p:nvSpPr>
           <p:spPr>
             <a:xfrm rot="0">
-              <a:off x="0" y="-190500"/>
-              <a:ext cx="5178984" cy="1369906"/>
+              <a:off x="0" y="-76200"/>
+              <a:ext cx="5486344" cy="1317059"/>
             </a:xfrm>
             <a:prstGeom prst="rect">
               <a:avLst/>
@@ -5012,18 +5008,18 @@
             <a:p>
               <a:pPr algn="l">
                 <a:lnSpc>
-                  <a:spcPts val="7574"/>
+                  <a:spcPts val="8023"/>
                 </a:lnSpc>
               </a:pPr>
               <a:r>
-                <a:rPr lang="en-US" sz="5826">
+                <a:rPr lang="en-US" sz="6171">
                   <a:solidFill>
                     <a:srgbClr val="FFFAEF"/>
                   </a:solidFill>
-                  <a:latin typeface="Jua"/>
-                  <a:ea typeface="Jua"/>
-                  <a:cs typeface="Jua"/>
-                  <a:sym typeface="Jua"/>
+                  <a:latin typeface="무궁화 고딕 Bold"/>
+                  <a:ea typeface="무궁화 고딕 Bold"/>
+                  <a:cs typeface="무궁화 고딕 Bold"/>
+                  <a:sym typeface="무궁화 고딕 Bold"/>
                 </a:rPr>
                 <a:t>STEP 2.</a:t>
               </a:r>
@@ -5121,8 +5117,8 @@
         </p:nvSpPr>
         <p:spPr>
           <a:xfrm rot="0">
-            <a:off x="2717556" y="3933825"/>
-            <a:ext cx="12852888" cy="2124075"/>
+            <a:off x="2717556" y="4219575"/>
+            <a:ext cx="12852888" cy="1838325"/>
           </a:xfrm>
           <a:prstGeom prst="rect">
             <a:avLst/>
@@ -5144,10 +5140,10 @@
                 <a:solidFill>
                   <a:srgbClr val="000000"/>
                 </a:solidFill>
-                <a:latin typeface="Jua"/>
-                <a:ea typeface="Jua"/>
-                <a:cs typeface="Jua"/>
-                <a:sym typeface="Jua"/>
+                <a:latin typeface="무궁화 고딕"/>
+                <a:ea typeface="무궁화 고딕"/>
+                <a:cs typeface="무궁화 고딕"/>
+                <a:sym typeface="무궁화 고딕"/>
               </a:rPr>
               <a:t>4년</a:t>
             </a:r>
@@ -5244,8 +5240,8 @@
         </p:nvSpPr>
         <p:spPr>
           <a:xfrm rot="0">
-            <a:off x="1135011" y="3190875"/>
-            <a:ext cx="16017978" cy="3629025"/>
+            <a:off x="1135011" y="3457575"/>
+            <a:ext cx="16017978" cy="3362325"/>
           </a:xfrm>
           <a:prstGeom prst="rect">
             <a:avLst/>
@@ -5267,10 +5263,10 @@
                 <a:solidFill>
                   <a:srgbClr val="000000"/>
                 </a:solidFill>
-                <a:latin typeface="Jua"/>
-                <a:ea typeface="Jua"/>
-                <a:cs typeface="Jua"/>
-                <a:sym typeface="Jua"/>
+                <a:latin typeface="무궁화 고딕"/>
+                <a:ea typeface="무궁화 고딕"/>
+                <a:cs typeface="무궁화 고딕"/>
+                <a:sym typeface="무궁화 고딕"/>
               </a:rPr>
               <a:t>세계에서 가장 큰</a:t>
             </a:r>
@@ -5286,10 +5282,10 @@
                 <a:solidFill>
                   <a:srgbClr val="000000"/>
                 </a:solidFill>
-                <a:latin typeface="Jua"/>
-                <a:ea typeface="Jua"/>
-                <a:cs typeface="Jua"/>
-                <a:sym typeface="Jua"/>
+                <a:latin typeface="무궁화 고딕"/>
+                <a:ea typeface="무궁화 고딕"/>
+                <a:cs typeface="무궁화 고딕"/>
+                <a:sym typeface="무궁화 고딕"/>
               </a:rPr>
               <a:t>대륙은 어디일까요?</a:t>
             </a:r>
@@ -5386,8 +5382,8 @@
         </p:nvSpPr>
         <p:spPr>
           <a:xfrm rot="0">
-            <a:off x="2717556" y="3933825"/>
-            <a:ext cx="12852888" cy="2124075"/>
+            <a:off x="2717556" y="4219575"/>
+            <a:ext cx="12852888" cy="1838325"/>
           </a:xfrm>
           <a:prstGeom prst="rect">
             <a:avLst/>
@@ -5409,10 +5405,10 @@
                 <a:solidFill>
                   <a:srgbClr val="000000"/>
                 </a:solidFill>
-                <a:latin typeface="Jua"/>
-                <a:ea typeface="Jua"/>
-                <a:cs typeface="Jua"/>
-                <a:sym typeface="Jua"/>
+                <a:latin typeface="무궁화 고딕"/>
+                <a:ea typeface="무궁화 고딕"/>
+                <a:cs typeface="무궁화 고딕"/>
+                <a:sym typeface="무궁화 고딕"/>
               </a:rPr>
               <a:t>아시아</a:t>
             </a:r>
@@ -5509,8 +5505,8 @@
         </p:nvSpPr>
         <p:spPr>
           <a:xfrm rot="0">
-            <a:off x="1135011" y="4029075"/>
-            <a:ext cx="16017978" cy="1952625"/>
+            <a:off x="1135011" y="4295775"/>
+            <a:ext cx="16017978" cy="1685925"/>
           </a:xfrm>
           <a:prstGeom prst="rect">
             <a:avLst/>
@@ -5532,10 +5528,10 @@
                 <a:solidFill>
                   <a:srgbClr val="000000"/>
                 </a:solidFill>
-                <a:latin typeface="Jua"/>
-                <a:ea typeface="Jua"/>
-                <a:cs typeface="Jua"/>
-                <a:sym typeface="Jua"/>
+                <a:latin typeface="무궁화 고딕"/>
+                <a:ea typeface="무궁화 고딕"/>
+                <a:cs typeface="무궁화 고딕"/>
+                <a:sym typeface="무궁화 고딕"/>
               </a:rPr>
               <a:t>물의 화학식은 무엇일까요?</a:t>
             </a:r>
@@ -5632,8 +5628,8 @@
         </p:nvSpPr>
         <p:spPr>
           <a:xfrm rot="0">
-            <a:off x="2717556" y="3933825"/>
-            <a:ext cx="12852888" cy="2124075"/>
+            <a:off x="2717556" y="4219575"/>
+            <a:ext cx="12852888" cy="1838325"/>
           </a:xfrm>
           <a:prstGeom prst="rect">
             <a:avLst/>
@@ -5655,10 +5651,10 @@
                 <a:solidFill>
                   <a:srgbClr val="000000"/>
                 </a:solidFill>
-                <a:latin typeface="Jua"/>
-                <a:ea typeface="Jua"/>
-                <a:cs typeface="Jua"/>
-                <a:sym typeface="Jua"/>
+                <a:latin typeface="무궁화 고딕"/>
+                <a:ea typeface="무궁화 고딕"/>
+                <a:cs typeface="무궁화 고딕"/>
+                <a:sym typeface="무궁화 고딕"/>
               </a:rPr>
               <a:t>H₂O</a:t>
             </a:r>
@@ -5755,8 +5751,8 @@
         </p:nvSpPr>
         <p:spPr>
           <a:xfrm rot="0">
-            <a:off x="1135011" y="4029075"/>
-            <a:ext cx="16017978" cy="1952625"/>
+            <a:off x="1135011" y="4367213"/>
+            <a:ext cx="16017978" cy="1543050"/>
           </a:xfrm>
           <a:prstGeom prst="rect">
             <a:avLst/>
@@ -5770,18 +5766,18 @@
           <a:p>
             <a:pPr algn="ctr">
               <a:lnSpc>
-                <a:spcPts val="13200"/>
+                <a:spcPts val="12120"/>
               </a:lnSpc>
             </a:pPr>
             <a:r>
-              <a:rPr lang="en-US" sz="11000">
+              <a:rPr lang="en-US" sz="10100">
                 <a:solidFill>
                   <a:srgbClr val="000000"/>
                 </a:solidFill>
-                <a:latin typeface="Jua"/>
-                <a:ea typeface="Jua"/>
-                <a:cs typeface="Jua"/>
-                <a:sym typeface="Jua"/>
+                <a:latin typeface="무궁화 고딕"/>
+                <a:ea typeface="무궁화 고딕"/>
+                <a:cs typeface="무궁화 고딕"/>
+                <a:sym typeface="무궁화 고딕"/>
               </a:rPr>
               <a:t>피아노 건반은 총 몇 개일까요?</a:t>
             </a:r>
@@ -5878,8 +5874,8 @@
         </p:nvSpPr>
         <p:spPr>
           <a:xfrm rot="0">
-            <a:off x="2717556" y="3933825"/>
-            <a:ext cx="12852888" cy="2124075"/>
+            <a:off x="2717556" y="4219575"/>
+            <a:ext cx="12852888" cy="1838325"/>
           </a:xfrm>
           <a:prstGeom prst="rect">
             <a:avLst/>
@@ -5901,10 +5897,10 @@
                 <a:solidFill>
                   <a:srgbClr val="000000"/>
                 </a:solidFill>
-                <a:latin typeface="Jua"/>
-                <a:ea typeface="Jua"/>
-                <a:cs typeface="Jua"/>
-                <a:sym typeface="Jua"/>
+                <a:latin typeface="무궁화 고딕"/>
+                <a:ea typeface="무궁화 고딕"/>
+                <a:cs typeface="무궁화 고딕"/>
+                <a:sym typeface="무궁화 고딕"/>
               </a:rPr>
               <a:t>88개</a:t>
             </a:r>
@@ -6001,8 +5997,8 @@
         </p:nvSpPr>
         <p:spPr>
           <a:xfrm rot="0">
-            <a:off x="1135011" y="3190875"/>
-            <a:ext cx="16017978" cy="3629025"/>
+            <a:off x="1135011" y="3457575"/>
+            <a:ext cx="16017978" cy="3362325"/>
           </a:xfrm>
           <a:prstGeom prst="rect">
             <a:avLst/>
@@ -6024,10 +6020,10 @@
                 <a:solidFill>
                   <a:srgbClr val="000000"/>
                 </a:solidFill>
-                <a:latin typeface="Jua"/>
-                <a:ea typeface="Jua"/>
-                <a:cs typeface="Jua"/>
-                <a:sym typeface="Jua"/>
+                <a:latin typeface="무궁화 고딕"/>
+                <a:ea typeface="무궁화 고딕"/>
+                <a:cs typeface="무궁화 고딕"/>
+                <a:sym typeface="무궁화 고딕"/>
               </a:rPr>
               <a:t>세계에서 가장 긴</a:t>
             </a:r>
@@ -6043,10 +6039,10 @@
                 <a:solidFill>
                   <a:srgbClr val="000000"/>
                 </a:solidFill>
-                <a:latin typeface="Jua"/>
-                <a:ea typeface="Jua"/>
-                <a:cs typeface="Jua"/>
-                <a:sym typeface="Jua"/>
+                <a:latin typeface="무궁화 고딕"/>
+                <a:ea typeface="무궁화 고딕"/>
+                <a:cs typeface="무궁화 고딕"/>
+                <a:sym typeface="무궁화 고딕"/>
               </a:rPr>
               <a:t>강은 어디일까요?</a:t>
             </a:r>
@@ -6143,8 +6139,8 @@
         </p:nvSpPr>
         <p:spPr>
           <a:xfrm rot="0">
-            <a:off x="2717556" y="3933825"/>
-            <a:ext cx="12852888" cy="2124075"/>
+            <a:off x="2717556" y="4219575"/>
+            <a:ext cx="12852888" cy="1838325"/>
           </a:xfrm>
           <a:prstGeom prst="rect">
             <a:avLst/>
@@ -6166,10 +6162,10 @@
                 <a:solidFill>
                   <a:srgbClr val="000000"/>
                 </a:solidFill>
-                <a:latin typeface="Jua"/>
-                <a:ea typeface="Jua"/>
-                <a:cs typeface="Jua"/>
-                <a:sym typeface="Jua"/>
+                <a:latin typeface="무궁화 고딕"/>
+                <a:ea typeface="무궁화 고딕"/>
+                <a:cs typeface="무궁화 고딕"/>
+                <a:sym typeface="무궁화 고딕"/>
               </a:rPr>
               <a:t>나일강</a:t>
             </a:r>
@@ -6266,8 +6262,8 @@
         </p:nvSpPr>
         <p:spPr>
           <a:xfrm rot="0">
-            <a:off x="1135011" y="3190875"/>
-            <a:ext cx="16017978" cy="3629025"/>
+            <a:off x="1135011" y="3457575"/>
+            <a:ext cx="16017978" cy="3362325"/>
           </a:xfrm>
           <a:prstGeom prst="rect">
             <a:avLst/>
@@ -6289,10 +6285,10 @@
                 <a:solidFill>
                   <a:srgbClr val="000000"/>
                 </a:solidFill>
-                <a:latin typeface="Jua"/>
-                <a:ea typeface="Jua"/>
-                <a:cs typeface="Jua"/>
-                <a:sym typeface="Jua"/>
+                <a:latin typeface="무궁화 고딕"/>
+                <a:ea typeface="무궁화 고딕"/>
+                <a:cs typeface="무궁화 고딕"/>
+                <a:sym typeface="무궁화 고딕"/>
               </a:rPr>
               <a:t>태양계 행성 중</a:t>
             </a:r>
@@ -6308,10 +6304,10 @@
                 <a:solidFill>
                   <a:srgbClr val="000000"/>
                 </a:solidFill>
-                <a:latin typeface="Jua"/>
-                <a:ea typeface="Jua"/>
-                <a:cs typeface="Jua"/>
-                <a:sym typeface="Jua"/>
+                <a:latin typeface="무궁화 고딕"/>
+                <a:ea typeface="무궁화 고딕"/>
+                <a:cs typeface="무궁화 고딕"/>
+                <a:sym typeface="무궁화 고딕"/>
               </a:rPr>
               <a:t>가장 큰 것은 무엇일까요?</a:t>
             </a:r>
@@ -6358,8 +6354,8 @@
         </p:nvSpPr>
         <p:spPr>
           <a:xfrm rot="0">
-            <a:off x="3238925" y="4092795"/>
-            <a:ext cx="11810151" cy="2200275"/>
+            <a:off x="3238925" y="4378545"/>
+            <a:ext cx="11810151" cy="1914525"/>
           </a:xfrm>
           <a:prstGeom prst="rect">
             <a:avLst/>
@@ -6381,10 +6377,10 @@
                 <a:solidFill>
                   <a:srgbClr val="000000"/>
                 </a:solidFill>
-                <a:latin typeface="Jua"/>
-                <a:ea typeface="Jua"/>
-                <a:cs typeface="Jua"/>
-                <a:sym typeface="Jua"/>
+                <a:latin typeface="무궁화 고딕"/>
+                <a:ea typeface="무궁화 고딕"/>
+                <a:cs typeface="무궁화 고딕"/>
+                <a:sym typeface="무궁화 고딕"/>
               </a:rPr>
               <a:t>팀을 나눠주세요!</a:t>
             </a:r>
@@ -6531,8 +6527,8 @@
         </p:nvSpPr>
         <p:spPr>
           <a:xfrm rot="0">
-            <a:off x="2717556" y="3933825"/>
-            <a:ext cx="12852888" cy="2124075"/>
+            <a:off x="2717556" y="4219575"/>
+            <a:ext cx="12852888" cy="1838325"/>
           </a:xfrm>
           <a:prstGeom prst="rect">
             <a:avLst/>
@@ -6554,10 +6550,10 @@
                 <a:solidFill>
                   <a:srgbClr val="000000"/>
                 </a:solidFill>
-                <a:latin typeface="Jua"/>
-                <a:ea typeface="Jua"/>
-                <a:cs typeface="Jua"/>
-                <a:sym typeface="Jua"/>
+                <a:latin typeface="무궁화 고딕"/>
+                <a:ea typeface="무궁화 고딕"/>
+                <a:cs typeface="무궁화 고딕"/>
+                <a:sym typeface="무궁화 고딕"/>
               </a:rPr>
               <a:t>목성</a:t>
             </a:r>
@@ -6654,8 +6650,8 @@
         </p:nvSpPr>
         <p:spPr>
           <a:xfrm rot="0">
-            <a:off x="1135011" y="3190875"/>
-            <a:ext cx="16017978" cy="3629025"/>
+            <a:off x="1135011" y="3457575"/>
+            <a:ext cx="16017978" cy="3362325"/>
           </a:xfrm>
           <a:prstGeom prst="rect">
             <a:avLst/>
@@ -6677,10 +6673,10 @@
                 <a:solidFill>
                   <a:srgbClr val="000000"/>
                 </a:solidFill>
-                <a:latin typeface="Jua"/>
-                <a:ea typeface="Jua"/>
-                <a:cs typeface="Jua"/>
-                <a:sym typeface="Jua"/>
+                <a:latin typeface="무궁화 고딕"/>
+                <a:ea typeface="무궁화 고딕"/>
+                <a:cs typeface="무궁화 고딕"/>
+                <a:sym typeface="무궁화 고딕"/>
               </a:rPr>
               <a:t>대한민국의 건국 연도는</a:t>
             </a:r>
@@ -6696,10 +6692,10 @@
                 <a:solidFill>
                   <a:srgbClr val="000000"/>
                 </a:solidFill>
-                <a:latin typeface="Jua"/>
-                <a:ea typeface="Jua"/>
-                <a:cs typeface="Jua"/>
-                <a:sym typeface="Jua"/>
+                <a:latin typeface="무궁화 고딕"/>
+                <a:ea typeface="무궁화 고딕"/>
+                <a:cs typeface="무궁화 고딕"/>
+                <a:sym typeface="무궁화 고딕"/>
               </a:rPr>
               <a:t>언제일까요?</a:t>
             </a:r>
@@ -6796,8 +6792,8 @@
         </p:nvSpPr>
         <p:spPr>
           <a:xfrm rot="0">
-            <a:off x="2717556" y="3933825"/>
-            <a:ext cx="12852888" cy="2124075"/>
+            <a:off x="2717556" y="4219575"/>
+            <a:ext cx="12852888" cy="1838325"/>
           </a:xfrm>
           <a:prstGeom prst="rect">
             <a:avLst/>
@@ -6819,10 +6815,10 @@
                 <a:solidFill>
                   <a:srgbClr val="000000"/>
                 </a:solidFill>
-                <a:latin typeface="Jua"/>
-                <a:ea typeface="Jua"/>
-                <a:cs typeface="Jua"/>
-                <a:sym typeface="Jua"/>
+                <a:latin typeface="무궁화 고딕"/>
+                <a:ea typeface="무궁화 고딕"/>
+                <a:cs typeface="무궁화 고딕"/>
+                <a:sym typeface="무궁화 고딕"/>
               </a:rPr>
               <a:t>1948년</a:t>
             </a:r>
@@ -6919,8 +6915,8 @@
         </p:nvSpPr>
         <p:spPr>
           <a:xfrm rot="0">
-            <a:off x="1135011" y="4029075"/>
-            <a:ext cx="16017978" cy="1952625"/>
+            <a:off x="1135011" y="4295775"/>
+            <a:ext cx="16017978" cy="1685925"/>
           </a:xfrm>
           <a:prstGeom prst="rect">
             <a:avLst/>
@@ -6942,10 +6938,10 @@
                 <a:solidFill>
                   <a:srgbClr val="000000"/>
                 </a:solidFill>
-                <a:latin typeface="Jua"/>
-                <a:ea typeface="Jua"/>
-                <a:cs typeface="Jua"/>
-                <a:sym typeface="Jua"/>
+                <a:latin typeface="무궁화 고딕"/>
+                <a:ea typeface="무궁화 고딕"/>
+                <a:cs typeface="무궁화 고딕"/>
+                <a:sym typeface="무궁화 고딕"/>
               </a:rPr>
               <a:t>빛의 삼원색은 무엇일까요?</a:t>
             </a:r>
@@ -7042,8 +7038,8 @@
         </p:nvSpPr>
         <p:spPr>
           <a:xfrm rot="0">
-            <a:off x="2717556" y="3933825"/>
-            <a:ext cx="12852888" cy="2124075"/>
+            <a:off x="2717556" y="4219575"/>
+            <a:ext cx="12852888" cy="1838325"/>
           </a:xfrm>
           <a:prstGeom prst="rect">
             <a:avLst/>
@@ -7065,10 +7061,10 @@
                 <a:solidFill>
                   <a:srgbClr val="000000"/>
                 </a:solidFill>
-                <a:latin typeface="Jua"/>
-                <a:ea typeface="Jua"/>
-                <a:cs typeface="Jua"/>
-                <a:sym typeface="Jua"/>
+                <a:latin typeface="무궁화 고딕"/>
+                <a:ea typeface="무궁화 고딕"/>
+                <a:cs typeface="무궁화 고딕"/>
+                <a:sym typeface="무궁화 고딕"/>
               </a:rPr>
               <a:t>빨강, 초록, 파랑</a:t>
             </a:r>
@@ -7165,8 +7161,8 @@
         </p:nvSpPr>
         <p:spPr>
           <a:xfrm rot="0">
-            <a:off x="1135011" y="3190875"/>
-            <a:ext cx="16017978" cy="3629025"/>
+            <a:off x="1135011" y="3457575"/>
+            <a:ext cx="16017978" cy="3362325"/>
           </a:xfrm>
           <a:prstGeom prst="rect">
             <a:avLst/>
@@ -7188,10 +7184,10 @@
                 <a:solidFill>
                   <a:srgbClr val="000000"/>
                 </a:solidFill>
-                <a:latin typeface="Jua"/>
-                <a:ea typeface="Jua"/>
-                <a:cs typeface="Jua"/>
-                <a:sym typeface="Jua"/>
+                <a:latin typeface="무궁화 고딕"/>
+                <a:ea typeface="무궁화 고딕"/>
+                <a:cs typeface="무궁화 고딕"/>
+                <a:sym typeface="무궁화 고딕"/>
               </a:rPr>
               <a:t>세계에서 가장 큰</a:t>
             </a:r>
@@ -7207,10 +7203,10 @@
                 <a:solidFill>
                   <a:srgbClr val="000000"/>
                 </a:solidFill>
-                <a:latin typeface="Jua"/>
-                <a:ea typeface="Jua"/>
-                <a:cs typeface="Jua"/>
-                <a:sym typeface="Jua"/>
+                <a:latin typeface="무궁화 고딕"/>
+                <a:ea typeface="무궁화 고딕"/>
+                <a:cs typeface="무궁화 고딕"/>
+                <a:sym typeface="무궁화 고딕"/>
               </a:rPr>
               <a:t>사막은 어디일까요?</a:t>
             </a:r>
@@ -7307,8 +7303,8 @@
         </p:nvSpPr>
         <p:spPr>
           <a:xfrm rot="0">
-            <a:off x="2717556" y="3933825"/>
-            <a:ext cx="12852888" cy="2124075"/>
+            <a:off x="2717556" y="4219575"/>
+            <a:ext cx="12852888" cy="1838325"/>
           </a:xfrm>
           <a:prstGeom prst="rect">
             <a:avLst/>
@@ -7330,10 +7326,10 @@
                 <a:solidFill>
                   <a:srgbClr val="000000"/>
                 </a:solidFill>
-                <a:latin typeface="Jua"/>
-                <a:ea typeface="Jua"/>
-                <a:cs typeface="Jua"/>
-                <a:sym typeface="Jua"/>
+                <a:latin typeface="무궁화 고딕"/>
+                <a:ea typeface="무궁화 고딕"/>
+                <a:cs typeface="무궁화 고딕"/>
+                <a:sym typeface="무궁화 고딕"/>
               </a:rPr>
               <a:t>사하라 사막</a:t>
             </a:r>
@@ -7430,8 +7426,8 @@
         </p:nvSpPr>
         <p:spPr>
           <a:xfrm rot="0">
-            <a:off x="1135011" y="3190875"/>
-            <a:ext cx="16017978" cy="3629025"/>
+            <a:off x="1135011" y="3457575"/>
+            <a:ext cx="16017978" cy="3362325"/>
           </a:xfrm>
           <a:prstGeom prst="rect">
             <a:avLst/>
@@ -7453,10 +7449,10 @@
                 <a:solidFill>
                   <a:srgbClr val="000000"/>
                 </a:solidFill>
-                <a:latin typeface="Jua"/>
-                <a:ea typeface="Jua"/>
-                <a:cs typeface="Jua"/>
-                <a:sym typeface="Jua"/>
+                <a:latin typeface="무궁화 고딕"/>
+                <a:ea typeface="무궁화 고딕"/>
+                <a:cs typeface="무궁화 고딕"/>
+                <a:sym typeface="무궁화 고딕"/>
               </a:rPr>
               <a:t>다이아몬드의 원소는</a:t>
             </a:r>
@@ -7472,10 +7468,10 @@
                 <a:solidFill>
                   <a:srgbClr val="000000"/>
                 </a:solidFill>
-                <a:latin typeface="Jua"/>
-                <a:ea typeface="Jua"/>
-                <a:cs typeface="Jua"/>
-                <a:sym typeface="Jua"/>
+                <a:latin typeface="무궁화 고딕"/>
+                <a:ea typeface="무궁화 고딕"/>
+                <a:cs typeface="무궁화 고딕"/>
+                <a:sym typeface="무궁화 고딕"/>
               </a:rPr>
               <a:t>무엇일까요?</a:t>
             </a:r>
@@ -7572,8 +7568,8 @@
         </p:nvSpPr>
         <p:spPr>
           <a:xfrm rot="0">
-            <a:off x="2717556" y="3933825"/>
-            <a:ext cx="12852888" cy="2124075"/>
+            <a:off x="2717556" y="4219575"/>
+            <a:ext cx="12852888" cy="1838325"/>
           </a:xfrm>
           <a:prstGeom prst="rect">
             <a:avLst/>
@@ -7595,10 +7591,10 @@
                 <a:solidFill>
                   <a:srgbClr val="000000"/>
                 </a:solidFill>
-                <a:latin typeface="Jua"/>
-                <a:ea typeface="Jua"/>
-                <a:cs typeface="Jua"/>
-                <a:sym typeface="Jua"/>
+                <a:latin typeface="무궁화 고딕"/>
+                <a:ea typeface="무궁화 고딕"/>
+                <a:cs typeface="무궁화 고딕"/>
+                <a:sym typeface="무궁화 고딕"/>
               </a:rPr>
               <a:t>탄소(C)</a:t>
             </a:r>
@@ -7695,8 +7691,8 @@
         </p:nvSpPr>
         <p:spPr>
           <a:xfrm rot="0">
-            <a:off x="1135011" y="3190875"/>
-            <a:ext cx="16017978" cy="3629025"/>
+            <a:off x="1135011" y="3457575"/>
+            <a:ext cx="16017978" cy="3362325"/>
           </a:xfrm>
           <a:prstGeom prst="rect">
             <a:avLst/>
@@ -7718,10 +7714,10 @@
                 <a:solidFill>
                   <a:srgbClr val="000000"/>
                 </a:solidFill>
-                <a:latin typeface="Jua"/>
-                <a:ea typeface="Jua"/>
-                <a:cs typeface="Jua"/>
-                <a:sym typeface="Jua"/>
+                <a:latin typeface="무궁화 고딕"/>
+                <a:ea typeface="무궁화 고딕"/>
+                <a:cs typeface="무궁화 고딕"/>
+                <a:sym typeface="무궁화 고딕"/>
               </a:rPr>
               <a:t>바둑판은 가로 세로</a:t>
             </a:r>
@@ -7737,10 +7733,10 @@
                 <a:solidFill>
                   <a:srgbClr val="000000"/>
                 </a:solidFill>
-                <a:latin typeface="Jua"/>
-                <a:ea typeface="Jua"/>
-                <a:cs typeface="Jua"/>
-                <a:sym typeface="Jua"/>
+                <a:latin typeface="무궁화 고딕"/>
+                <a:ea typeface="무궁화 고딕"/>
+                <a:cs typeface="무궁화 고딕"/>
+                <a:sym typeface="무궁화 고딕"/>
               </a:rPr>
               <a:t>몇 줄일까요?</a:t>
             </a:r>
@@ -7837,8 +7833,8 @@
         </p:nvSpPr>
         <p:spPr>
           <a:xfrm rot="0">
-            <a:off x="1028700" y="3892867"/>
-            <a:ext cx="15555091" cy="2200275"/>
+            <a:off x="1028700" y="4178617"/>
+            <a:ext cx="15555091" cy="1914525"/>
           </a:xfrm>
           <a:prstGeom prst="rect">
             <a:avLst/>
@@ -7860,10 +7856,10 @@
                 <a:solidFill>
                   <a:srgbClr val="FFFAEF"/>
                 </a:solidFill>
-                <a:latin typeface="Jua"/>
-                <a:ea typeface="Jua"/>
-                <a:cs typeface="Jua"/>
-                <a:sym typeface="Jua"/>
+                <a:latin typeface="무궁화 고딕"/>
+                <a:ea typeface="무궁화 고딕"/>
+                <a:cs typeface="무궁화 고딕"/>
+                <a:sym typeface="무궁화 고딕"/>
               </a:rPr>
               <a:t>상식 퀴즈</a:t>
             </a:r>
@@ -7878,8 +7874,8 @@
         </p:nvSpPr>
         <p:spPr>
           <a:xfrm rot="0">
-            <a:off x="15264803" y="9812655"/>
-            <a:ext cx="2637975" cy="474345"/>
+            <a:off x="14683277" y="9822180"/>
+            <a:ext cx="3219502" cy="464820"/>
           </a:xfrm>
           <a:prstGeom prst="rect">
             <a:avLst/>
@@ -7904,10 +7900,10 @@
                 <a:solidFill>
                   <a:srgbClr val="FFFFFF"/>
                 </a:solidFill>
-                <a:latin typeface="TDTD갬성명조"/>
-                <a:ea typeface="TDTD갬성명조"/>
-                <a:cs typeface="TDTD갬성명조"/>
-                <a:sym typeface="TDTD갬성명조"/>
+                <a:latin typeface="무궁화 고딕"/>
+                <a:ea typeface="무궁화 고딕"/>
+                <a:cs typeface="무궁화 고딕"/>
+                <a:sym typeface="무궁화 고딕"/>
               </a:rPr>
               <a:t>ⓒ 2026. Sunday Play</a:t>
             </a:r>
@@ -8004,8 +8000,8 @@
         </p:nvSpPr>
         <p:spPr>
           <a:xfrm rot="0">
-            <a:off x="2717556" y="3933825"/>
-            <a:ext cx="12852888" cy="2124075"/>
+            <a:off x="2717556" y="4219575"/>
+            <a:ext cx="12852888" cy="1838325"/>
           </a:xfrm>
           <a:prstGeom prst="rect">
             <a:avLst/>
@@ -8027,10 +8023,10 @@
                 <a:solidFill>
                   <a:srgbClr val="000000"/>
                 </a:solidFill>
-                <a:latin typeface="Jua"/>
-                <a:ea typeface="Jua"/>
-                <a:cs typeface="Jua"/>
-                <a:sym typeface="Jua"/>
+                <a:latin typeface="무궁화 고딕"/>
+                <a:ea typeface="무궁화 고딕"/>
+                <a:cs typeface="무궁화 고딕"/>
+                <a:sym typeface="무궁화 고딕"/>
               </a:rPr>
               <a:t>19줄</a:t>
             </a:r>
@@ -8127,8 +8123,8 @@
         </p:nvSpPr>
         <p:spPr>
           <a:xfrm rot="0">
-            <a:off x="1135011" y="3190875"/>
-            <a:ext cx="16017978" cy="3629025"/>
+            <a:off x="1135011" y="3457575"/>
+            <a:ext cx="16017978" cy="3362325"/>
           </a:xfrm>
           <a:prstGeom prst="rect">
             <a:avLst/>
@@ -8150,10 +8146,10 @@
                 <a:solidFill>
                   <a:srgbClr val="000000"/>
                 </a:solidFill>
-                <a:latin typeface="Jua"/>
-                <a:ea typeface="Jua"/>
-                <a:cs typeface="Jua"/>
-                <a:sym typeface="Jua"/>
+                <a:latin typeface="무궁화 고딕"/>
+                <a:ea typeface="무궁화 고딕"/>
+                <a:cs typeface="무궁화 고딕"/>
+                <a:sym typeface="무궁화 고딕"/>
               </a:rPr>
               <a:t>세계에서 가장 깊은</a:t>
             </a:r>
@@ -8169,10 +8165,10 @@
                 <a:solidFill>
                   <a:srgbClr val="000000"/>
                 </a:solidFill>
-                <a:latin typeface="Jua"/>
-                <a:ea typeface="Jua"/>
-                <a:cs typeface="Jua"/>
-                <a:sym typeface="Jua"/>
+                <a:latin typeface="무궁화 고딕"/>
+                <a:ea typeface="무궁화 고딕"/>
+                <a:cs typeface="무궁화 고딕"/>
+                <a:sym typeface="무궁화 고딕"/>
               </a:rPr>
               <a:t>바다는 어디일까요?</a:t>
             </a:r>
@@ -8269,8 +8265,8 @@
         </p:nvSpPr>
         <p:spPr>
           <a:xfrm rot="0">
-            <a:off x="2717556" y="3933825"/>
-            <a:ext cx="12852888" cy="2124075"/>
+            <a:off x="2717556" y="4219575"/>
+            <a:ext cx="12852888" cy="1838325"/>
           </a:xfrm>
           <a:prstGeom prst="rect">
             <a:avLst/>
@@ -8292,10 +8288,10 @@
                 <a:solidFill>
                   <a:srgbClr val="000000"/>
                 </a:solidFill>
-                <a:latin typeface="Jua"/>
-                <a:ea typeface="Jua"/>
-                <a:cs typeface="Jua"/>
-                <a:sym typeface="Jua"/>
+                <a:latin typeface="무궁화 고딕"/>
+                <a:ea typeface="무궁화 고딕"/>
+                <a:cs typeface="무궁화 고딕"/>
+                <a:sym typeface="무궁화 고딕"/>
               </a:rPr>
               <a:t>마리아나 해구</a:t>
             </a:r>
@@ -8392,8 +8388,8 @@
         </p:nvSpPr>
         <p:spPr>
           <a:xfrm rot="0">
-            <a:off x="1135011" y="3190875"/>
-            <a:ext cx="16017978" cy="3629025"/>
+            <a:off x="1135011" y="3457575"/>
+            <a:ext cx="16017978" cy="3362325"/>
           </a:xfrm>
           <a:prstGeom prst="rect">
             <a:avLst/>
@@ -8415,10 +8411,10 @@
                 <a:solidFill>
                   <a:srgbClr val="000000"/>
                 </a:solidFill>
-                <a:latin typeface="Jua"/>
-                <a:ea typeface="Jua"/>
-                <a:cs typeface="Jua"/>
-                <a:sym typeface="Jua"/>
+                <a:latin typeface="무궁화 고딕"/>
+                <a:ea typeface="무궁화 고딕"/>
+                <a:cs typeface="무궁화 고딕"/>
+                <a:sym typeface="무궁화 고딕"/>
               </a:rPr>
               <a:t>최초로 달에 착륙한</a:t>
             </a:r>
@@ -8434,10 +8430,10 @@
                 <a:solidFill>
                   <a:srgbClr val="000000"/>
                 </a:solidFill>
-                <a:latin typeface="Jua"/>
-                <a:ea typeface="Jua"/>
-                <a:cs typeface="Jua"/>
-                <a:sym typeface="Jua"/>
+                <a:latin typeface="무궁화 고딕"/>
+                <a:ea typeface="무궁화 고딕"/>
+                <a:cs typeface="무궁화 고딕"/>
+                <a:sym typeface="무궁화 고딕"/>
               </a:rPr>
               <a:t>사람은 누구일까요?</a:t>
             </a:r>
@@ -8534,8 +8530,8 @@
         </p:nvSpPr>
         <p:spPr>
           <a:xfrm rot="0">
-            <a:off x="2717556" y="3933825"/>
-            <a:ext cx="12852888" cy="2124075"/>
+            <a:off x="2717556" y="4219575"/>
+            <a:ext cx="12852888" cy="1838325"/>
           </a:xfrm>
           <a:prstGeom prst="rect">
             <a:avLst/>
@@ -8557,10 +8553,10 @@
                 <a:solidFill>
                   <a:srgbClr val="000000"/>
                 </a:solidFill>
-                <a:latin typeface="Jua"/>
-                <a:ea typeface="Jua"/>
-                <a:cs typeface="Jua"/>
-                <a:sym typeface="Jua"/>
+                <a:latin typeface="무궁화 고딕"/>
+                <a:ea typeface="무궁화 고딕"/>
+                <a:cs typeface="무궁화 고딕"/>
+                <a:sym typeface="무궁화 고딕"/>
               </a:rPr>
               <a:t>닐 암스트롱</a:t>
             </a:r>
@@ -8632,8 +8628,8 @@
         </p:nvSpPr>
         <p:spPr>
           <a:xfrm rot="0">
-            <a:off x="4421807" y="3895725"/>
-            <a:ext cx="9444385" cy="2200275"/>
+            <a:off x="4421807" y="4181475"/>
+            <a:ext cx="9444385" cy="1914525"/>
           </a:xfrm>
           <a:prstGeom prst="rect">
             <a:avLst/>
@@ -8655,10 +8651,10 @@
                 <a:solidFill>
                   <a:srgbClr val="000000"/>
                 </a:solidFill>
-                <a:latin typeface="Jua"/>
-                <a:ea typeface="Jua"/>
-                <a:cs typeface="Jua"/>
-                <a:sym typeface="Jua"/>
+                <a:latin typeface="무궁화 고딕"/>
+                <a:ea typeface="무궁화 고딕"/>
+                <a:cs typeface="무궁화 고딕"/>
+                <a:sym typeface="무궁화 고딕"/>
               </a:rPr>
               <a:t>감사합니다!</a:t>
             </a:r>
@@ -8805,8 +8801,8 @@
         </p:nvSpPr>
         <p:spPr>
           <a:xfrm rot="0">
-            <a:off x="1135011" y="4029075"/>
-            <a:ext cx="16017978" cy="1952625"/>
+            <a:off x="1135011" y="4295775"/>
+            <a:ext cx="16017978" cy="1685925"/>
           </a:xfrm>
           <a:prstGeom prst="rect">
             <a:avLst/>
@@ -8828,10 +8824,10 @@
                 <a:solidFill>
                   <a:srgbClr val="000000"/>
                 </a:solidFill>
-                <a:latin typeface="Jua"/>
-                <a:ea typeface="Jua"/>
-                <a:cs typeface="Jua"/>
-                <a:sym typeface="Jua"/>
+                <a:latin typeface="무궁화 고딕"/>
+                <a:ea typeface="무궁화 고딕"/>
+                <a:cs typeface="무궁화 고딕"/>
+                <a:sym typeface="무궁화 고딕"/>
               </a:rPr>
               <a:t>무지개는 몇 가지 색일까요? </a:t>
             </a:r>
@@ -8928,8 +8924,8 @@
         </p:nvSpPr>
         <p:spPr>
           <a:xfrm rot="0">
-            <a:off x="2717556" y="3933825"/>
-            <a:ext cx="12852888" cy="2124075"/>
+            <a:off x="2717556" y="4219575"/>
+            <a:ext cx="12852888" cy="1838325"/>
           </a:xfrm>
           <a:prstGeom prst="rect">
             <a:avLst/>
@@ -8951,10 +8947,10 @@
                 <a:solidFill>
                   <a:srgbClr val="000000"/>
                 </a:solidFill>
-                <a:latin typeface="Jua"/>
-                <a:ea typeface="Jua"/>
-                <a:cs typeface="Jua"/>
-                <a:sym typeface="Jua"/>
+                <a:latin typeface="무궁화 고딕"/>
+                <a:ea typeface="무궁화 고딕"/>
+                <a:cs typeface="무궁화 고딕"/>
+                <a:sym typeface="무궁화 고딕"/>
               </a:rPr>
               <a:t>7가지</a:t>
             </a:r>
@@ -9051,8 +9047,8 @@
         </p:nvSpPr>
         <p:spPr>
           <a:xfrm rot="0">
-            <a:off x="1135011" y="4029075"/>
-            <a:ext cx="16017978" cy="1952625"/>
+            <a:off x="1135011" y="4295775"/>
+            <a:ext cx="16017978" cy="1685925"/>
           </a:xfrm>
           <a:prstGeom prst="rect">
             <a:avLst/>
@@ -9074,10 +9070,10 @@
                 <a:solidFill>
                   <a:srgbClr val="000000"/>
                 </a:solidFill>
-                <a:latin typeface="Jua"/>
-                <a:ea typeface="Jua"/>
-                <a:cs typeface="Jua"/>
-                <a:sym typeface="Jua"/>
+                <a:latin typeface="무궁화 고딕"/>
+                <a:ea typeface="무궁화 고딕"/>
+                <a:cs typeface="무궁화 고딕"/>
+                <a:sym typeface="무궁화 고딕"/>
               </a:rPr>
               <a:t>1년은 몇 주일까요?</a:t>
             </a:r>
@@ -9174,8 +9170,8 @@
         </p:nvSpPr>
         <p:spPr>
           <a:xfrm rot="0">
-            <a:off x="2717556" y="3933825"/>
-            <a:ext cx="12852888" cy="2124075"/>
+            <a:off x="2717556" y="4219575"/>
+            <a:ext cx="12852888" cy="1838325"/>
           </a:xfrm>
           <a:prstGeom prst="rect">
             <a:avLst/>
@@ -9197,10 +9193,10 @@
                 <a:solidFill>
                   <a:srgbClr val="000000"/>
                 </a:solidFill>
-                <a:latin typeface="Jua"/>
-                <a:ea typeface="Jua"/>
-                <a:cs typeface="Jua"/>
-                <a:sym typeface="Jua"/>
+                <a:latin typeface="무궁화 고딕"/>
+                <a:ea typeface="무궁화 고딕"/>
+                <a:cs typeface="무궁화 고딕"/>
+                <a:sym typeface="무궁화 고딕"/>
               </a:rPr>
               <a:t>52주</a:t>
             </a:r>
@@ -9297,8 +9293,8 @@
         </p:nvSpPr>
         <p:spPr>
           <a:xfrm rot="0">
-            <a:off x="1135011" y="4114800"/>
-            <a:ext cx="16017978" cy="1809750"/>
+            <a:off x="1135011" y="4391025"/>
+            <a:ext cx="16017978" cy="1495425"/>
           </a:xfrm>
           <a:prstGeom prst="rect">
             <a:avLst/>
@@ -9312,18 +9308,18 @@
           <a:p>
             <a:pPr algn="ctr">
               <a:lnSpc>
-                <a:spcPts val="12360"/>
+                <a:spcPts val="11760"/>
               </a:lnSpc>
             </a:pPr>
             <a:r>
-              <a:rPr lang="en-US" sz="10300">
+              <a:rPr lang="en-US" sz="9800">
                 <a:solidFill>
                   <a:srgbClr val="000000"/>
                 </a:solidFill>
-                <a:latin typeface="Jua"/>
-                <a:ea typeface="Jua"/>
-                <a:cs typeface="Jua"/>
-                <a:sym typeface="Jua"/>
+                <a:latin typeface="무궁화 고딕"/>
+                <a:ea typeface="무궁화 고딕"/>
+                <a:cs typeface="무궁화 고딕"/>
+                <a:sym typeface="무궁화 고딕"/>
               </a:rPr>
               <a:t>한글을 만든 사람은 누구일까요? </a:t>
             </a:r>

</xml_diff>